<commit_message>
Weekly update: all synthetic numbers on the full 50-sheet val split
Co-Authored-By: Claude Fable 5.1 <noreply@anthropic.com>
</commit_message>
<xml_diff>
--- a/weekly_update/2026-09-21_pipeline_accuracy_update.pptx
+++ b/weekly_update/2026-09-21_pipeline_accuracy_update.pptx
@@ -3545,7 +3545,7 @@
               </a:defRPr>
             </a:pPr>
             <a:r>
-              <a:t>•  Connectivity: a junction-aware assembler replaces endpoint chaining; edge F1 0.14 -&gt; 1.00 with perfect inputs, 0.99 with predicted inputs.</a:t>
+              <a:t>•  Connectivity: a junction-aware assembler replaces endpoint chaining; edge F1 0.12 -&gt; 1.00 with perfect inputs, 0.99 with predicted inputs.</a:t>
             </a:r>
           </a:p>
           <a:p>
@@ -4178,7 +4178,7 @@
               </a:defRPr>
             </a:pPr>
             <a:r>
-              <a:t>16 held-out synthetic sheets, all GT lines, 8 px tolerance</a:t>
+              <a:t>50 held-out synthetic sheets, all GT lines, 8 px tolerance</a:t>
             </a:r>
           </a:p>
         </p:txBody>
@@ -4338,7 +4338,7 @@
                         </a:defRPr>
                       </a:pPr>
                       <a:r>
-                        <a:t>0.884</a:t>
+                        <a:t>0.895</a:t>
                       </a:r>
                     </a:p>
                   </a:txBody>
@@ -4361,7 +4361,7 @@
                         </a:defRPr>
                       </a:pPr>
                       <a:r>
-                        <a:t>0.753</a:t>
+                        <a:t>0.755</a:t>
                       </a:r>
                     </a:p>
                   </a:txBody>
@@ -4384,7 +4384,7 @@
                         </a:defRPr>
                       </a:pPr>
                       <a:r>
-                        <a:t>0.811</a:t>
+                        <a:t>0.817</a:t>
                       </a:r>
                     </a:p>
                   </a:txBody>
@@ -4432,7 +4432,7 @@
                         </a:defRPr>
                       </a:pPr>
                       <a:r>
-                        <a:t>0.992</a:t>
+                        <a:t>0.994</a:t>
                       </a:r>
                     </a:p>
                   </a:txBody>
@@ -4455,7 +4455,7 @@
                         </a:defRPr>
                       </a:pPr>
                       <a:r>
-                        <a:t>0.882</a:t>
+                        <a:t>0.876</a:t>
                       </a:r>
                     </a:p>
                   </a:txBody>
@@ -4478,7 +4478,7 @@
                         </a:defRPr>
                       </a:pPr>
                       <a:r>
-                        <a:t>0.933</a:t>
+                        <a:t>0.931</a:t>
                       </a:r>
                     </a:p>
                   </a:txBody>
@@ -4526,7 +4526,7 @@
                         </a:defRPr>
                       </a:pPr>
                       <a:r>
-                        <a:t>0.974</a:t>
+                        <a:t>0.976</a:t>
                       </a:r>
                     </a:p>
                   </a:txBody>
@@ -5008,7 +5008,7 @@
               </a:defRPr>
             </a:pPr>
             <a:r>
-              <a:t>GT symbols + GT lines, 16 sheets</a:t>
+              <a:t>GT symbols + GT lines, 50 sheets</a:t>
             </a:r>
           </a:p>
         </p:txBody>
@@ -5144,7 +5144,7 @@
                         </a:defRPr>
                       </a:pPr>
                       <a:r>
-                        <a:t>0.136</a:t>
+                        <a:t>0.124</a:t>
                       </a:r>
                     </a:p>
                   </a:txBody>
@@ -5167,7 +5167,7 @@
                         </a:defRPr>
                       </a:pPr>
                       <a:r>
-                        <a:t>0.360</a:t>
+                        <a:t>0.361</a:t>
                       </a:r>
                     </a:p>
                   </a:txBody>
@@ -5366,7 +5366,7 @@
               </a:defRPr>
             </a:pPr>
             <a:r>
-              <a:t>Ablation ladder, 16 sheets, edge F1</a:t>
+              <a:t>Ablation ladder, 50 sheets, edge F1</a:t>
             </a:r>
           </a:p>
         </p:txBody>
@@ -5667,7 +5667,7 @@
                         </a:defRPr>
                       </a:pPr>
                       <a:r>
-                        <a:t>0.783</a:t>
+                        <a:t>0.759</a:t>
                       </a:r>
                     </a:p>
                   </a:txBody>

</xml_diff>

<commit_message>
U-Net retrained on all 450 train sheets: line F1 0.986, edge F1 0.991 on the 50 val sheets
Co-Authored-By: Claude Fable 5.1 <noreply@anthropic.com>
</commit_message>
<xml_diff>
--- a/weekly_update/2026-09-21_pipeline_accuracy_update.pptx
+++ b/weekly_update/2026-09-21_pipeline_accuracy_update.pptx
@@ -3530,7 +3530,7 @@
               </a:defRPr>
             </a:pPr>
             <a:r>
-              <a:t>•  Line detection: a learned U-Net extractor lifts F1 from 0.81 to 0.98 on held-out synthetic sheets and transfers visually to real drawings.</a:t>
+              <a:t>•  Line detection: a learned U-Net extractor lifts F1 from 0.82 to 0.99 on held-out synthetic sheets and transfers visually to real drawings.</a:t>
             </a:r>
           </a:p>
           <a:p>
@@ -4526,7 +4526,7 @@
                         </a:defRPr>
                       </a:pPr>
                       <a:r>
-                        <a:t>0.976</a:t>
+                        <a:t>0.981</a:t>
                       </a:r>
                     </a:p>
                   </a:txBody>
@@ -4549,7 +4549,7 @@
                         </a:defRPr>
                       </a:pPr>
                       <a:r>
-                        <a:t>0.992</a:t>
+                        <a:t>0.991</a:t>
                       </a:r>
                     </a:p>
                   </a:txBody>
@@ -4572,7 +4572,7 @@
                         </a:defRPr>
                       </a:pPr>
                       <a:r>
-                        <a:t>0.983</a:t>
+                        <a:t>0.986</a:t>
                       </a:r>
                     </a:p>
                   </a:txBody>
@@ -4771,7 +4771,7 @@
               </a:defRPr>
             </a:pPr>
             <a:r>
-              <a:t>•  25 minutes on one GPU, 45 training sheets. Recall 0.75 -&gt; 0.99.</a:t>
+              <a:t>35 minutes on one GPU, 450 training sheets. Recall 0.76 -&gt; 0.99.</a:t>
             </a:r>
           </a:p>
         </p:txBody>
@@ -5738,7 +5738,7 @@
                         </a:defRPr>
                       </a:pPr>
                       <a:r>
-                        <a:t>0.987</a:t>
+                        <a:t>0.991</a:t>
                       </a:r>
                     </a:p>
                   </a:txBody>

</xml_diff>

<commit_message>
U-Net line extractor is the default line stage
pnid_lineseg.py: model, tiled inference, mask -> segments, inner-frame and
notes-column masks; weights/lineseg_unet_450.pt (31 MB, distributed
separately like the symbol weights). process_text_lines.py step 4 defaults to
it, runs it through --line-python when this env lacks torch, and falls back to
the classical Hough stage (method="classical (fallback)"). process_single_pnid.py
passes its own interpreter as --line-python. eval_tools/line_seg.py imports
the repo module instead of duplicating it; eval_lines.py gains --variant unet.

50 val sheets: line count F1 0.995 (P 0.998 / R 0.992), edge F1 with YOLO
symbols 0.994, sheet-exact 0.32. Real drawing end to end: 154 lines, 158 links,
no frame tracing. Metric stress test (shift / drop / swap lines) documented in
weekly_update FINDINGS.

Co-Authored-By: Claude Fable 5.1 <noreply@anthropic.com>
</commit_message>
<xml_diff>
--- a/weekly_update/2026-09-21_pipeline_accuracy_update.pptx
+++ b/weekly_update/2026-09-21_pipeline_accuracy_update.pptx
@@ -4526,7 +4526,7 @@
                         </a:defRPr>
                       </a:pPr>
                       <a:r>
-                        <a:t>0.981</a:t>
+                        <a:t>0.998</a:t>
                       </a:r>
                     </a:p>
                   </a:txBody>
@@ -4549,7 +4549,7 @@
                         </a:defRPr>
                       </a:pPr>
                       <a:r>
-                        <a:t>0.991</a:t>
+                        <a:t>0.992</a:t>
                       </a:r>
                     </a:p>
                   </a:txBody>
@@ -4572,7 +4572,7 @@
                         </a:defRPr>
                       </a:pPr>
                       <a:r>
-                        <a:t>0.986</a:t>
+                        <a:t>0.995</a:t>
                       </a:r>
                     </a:p>
                   </a:txBody>
@@ -4771,7 +4771,7 @@
               </a:defRPr>
             </a:pPr>
             <a:r>
-              <a:t>35 minutes on one GPU, 450 training sheets. Recall 0.76 -&gt; 0.99.</a:t>
+              <a:t>35 minutes on one GPU, 450 training sheets. Recall 0.76 -&gt; 0.99. Now the default line stage (classical Hough kept as fallback).</a:t>
             </a:r>
           </a:p>
         </p:txBody>
@@ -4928,7 +4928,7 @@
               </a:defRPr>
             </a:pPr>
             <a:r>
-              <a:t>•  Both miss light-grey pipes on one drawing; U-Net also traces the drawing frame.</a:t>
+              <a:t>Both miss light-grey pipes on one drawing. Frame tracing fixed with the inner-frame mask.</a:t>
             </a:r>
           </a:p>
           <a:p>
@@ -5738,7 +5738,7 @@
                         </a:defRPr>
                       </a:pPr>
                       <a:r>
-                        <a:t>0.991</a:t>
+                        <a:t>0.994</a:t>
                       </a:r>
                     </a:p>
                   </a:txBody>

</xml_diff>